<commit_message>
Fix list line-height and kerning wrapping sync issue
</commit_message>
<xml_diff>
--- a/gallery/renders/markdown_lists_complex.pptx
+++ b/gallery/renders/markdown_lists_complex.pptx
@@ -35,7 +35,7 @@
         <p:spPr>
           <a:xfrm>
             <a:off x="910336" y="2092147"/>
-            <a:ext cx="11184128" cy="3901440"/>
+            <a:ext cx="11184128" cy="3600450"/>
           </a:xfrm>
           <a:prstGeom prst="rect">
             <a:avLst/>
@@ -50,7 +50,7 @@
               <a:buNone/>
             </a:pPr>
             <a:r>
-              <a:rPr lang="en-US" sz="2000">
+              <a:rPr lang="en-US" sz="2100">
                 <a:latin typeface="Arial"/>
               </a:rPr>
               <a:t>Here is a list to test multi-level indentation and line height continuity:</a:t>
@@ -62,31 +62,31 @@
               <a:buChar char="•"/>
             </a:pPr>
             <a:r>
-              <a:rPr lang="en-US" sz="2000">
+              <a:rPr lang="en-US" sz="2100">
                 <a:latin typeface="Arial"/>
               </a:rPr>
               <a:t>Level 1 Bullet</a:t>
             </a:r>
             <a:r>
-              <a:rPr lang="en-US" sz="2000">
+              <a:rPr lang="en-US" sz="2100">
                 <a:latin typeface="Arial"/>
               </a:rPr>
               <a:t>Level 2 Bullet</a:t>
             </a:r>
             <a:r>
-              <a:rPr lang="en-US" sz="2000">
+              <a:rPr lang="en-US" sz="2100">
                 <a:latin typeface="Arial"/>
               </a:rPr>
               <a:t>Level 3 Bullet</a:t>
             </a:r>
             <a:r>
-              <a:rPr lang="en-US" sz="2000">
+              <a:rPr lang="en-US" sz="2100">
                 <a:latin typeface="Arial"/>
               </a:rPr>
               <a:t>Level 4 Bullet</a:t>
             </a:r>
             <a:r>
-              <a:rPr lang="en-US" sz="2000">
+              <a:rPr lang="en-US" sz="2100">
                 <a:latin typeface="Arial"/>
               </a:rPr>
               <a:t>Level 5 Bullet</a:t>
@@ -97,13 +97,13 @@
               <a:buAutoNum type="arabicPeriod"/>
             </a:pPr>
             <a:r>
-              <a:rPr lang="en-US" sz="2000">
+              <a:rPr lang="en-US" sz="2100">
                 <a:latin typeface="Arial"/>
               </a:rPr>
               <a:t>Ordered List Item 1</a:t>
             </a:r>
             <a:r>
-              <a:rPr lang="en-US" sz="2000">
+              <a:rPr lang="en-US" sz="2100">
                 <a:latin typeface="Arial"/>
               </a:rPr>
               <a:t>Nested Ordered List Item 1</a:t>
@@ -114,7 +114,7 @@
               <a:buAutoNum type="arabicPeriod"/>
             </a:pPr>
             <a:r>
-              <a:rPr lang="en-US" sz="2000">
+              <a:rPr lang="en-US" sz="2100">
                 <a:latin typeface="Arial"/>
               </a:rPr>
               <a:t>Nested Ordered List Item 2</a:t>
@@ -125,13 +125,13 @@
               <a:buAutoNum type="arabicPeriod"/>
             </a:pPr>
             <a:r>
-              <a:rPr lang="en-US" sz="2000">
+              <a:rPr lang="en-US" sz="2100">
                 <a:latin typeface="Arial"/>
               </a:rPr>
               <a:t>Ordered List Item 2</a:t>
             </a:r>
             <a:r>
-              <a:rPr lang="en-US" sz="2000">
+              <a:rPr lang="en-US" sz="2100">
                 <a:latin typeface="Arial"/>
               </a:rPr>
               <a:t>Mixed Unordered Item 1</a:t>
@@ -143,7 +143,7 @@
               <a:buChar char="•"/>
             </a:pPr>
             <a:r>
-              <a:rPr lang="en-US" sz="2000">
+              <a:rPr lang="en-US" sz="2100">
                 <a:latin typeface="Arial"/>
               </a:rPr>
               <a:t>Mixed Unordered Item 2</a:t>
@@ -155,13 +155,13 @@
               <a:buChar char="•"/>
             </a:pPr>
             <a:r>
-              <a:rPr lang="en-US" sz="2000">
+              <a:rPr lang="en-US" sz="2100">
                 <a:latin typeface="Arial"/>
               </a:rPr>
               <a:t>A very long list item to test how text wraps when indented. We want to ensure that the second line of the bullet point lines up exactly with the first line of the text, rather than wrapping all the way to the left margin. This is crucial for readability.</a:t>
             </a:r>
             <a:r>
-              <a:rPr lang="en-US" sz="2000">
+              <a:rPr lang="en-US" sz="2100">
                 <a:latin typeface="Arial"/>
               </a:rPr>
               <a:t>Another very long nested list item to verify that the indentation margin is additive. The wrap margin should perfectly align with the bullet point's indent level.</a:t>

</xml_diff>

<commit_message>
Fix nested list rendering by flushing AST paragraphs on list/item boundaries
</commit_message>
<xml_diff>
--- a/gallery/renders/markdown_lists_complex.pptx
+++ b/gallery/renders/markdown_lists_complex.pptx
@@ -35,7 +35,7 @@
         <p:spPr>
           <a:xfrm>
             <a:off x="910336" y="2092147"/>
-            <a:ext cx="11184128" cy="3771900"/>
+            <a:ext cx="11184128" cy="3781425"/>
           </a:xfrm>
           <a:prstGeom prst="rect">
             <a:avLst/>
@@ -50,7 +50,7 @@
               <a:buNone/>
             </a:pPr>
             <a:r>
-              <a:rPr lang="en-US" sz="2200">
+              <a:rPr lang="en-US" sz="1500">
                 <a:latin typeface="Arial"/>
               </a:rPr>
               <a:t>Here is a list to test multi-level indentation and line height continuity:</a:t>
@@ -62,31 +62,55 @@
               <a:buChar char="•"/>
             </a:pPr>
             <a:r>
-              <a:rPr lang="en-US" sz="2200">
+              <a:rPr lang="en-US" sz="1500">
                 <a:latin typeface="Arial"/>
               </a:rPr>
               <a:t>Level 1 Bullet</a:t>
             </a:r>
-            <a:r>
-              <a:rPr lang="en-US" sz="2200">
+          </a:p>
+          <a:p>
+            <a:pPr algn="l" lvl="1" marL="685800" indent="-342900">
+              <a:buFont typeface="Arial"/>
+              <a:buChar char="•"/>
+            </a:pPr>
+            <a:r>
+              <a:rPr lang="en-US" sz="1500">
                 <a:latin typeface="Arial"/>
               </a:rPr>
               <a:t>Level 2 Bullet</a:t>
             </a:r>
-            <a:r>
-              <a:rPr lang="en-US" sz="2200">
+          </a:p>
+          <a:p>
+            <a:pPr algn="l" lvl="2" marL="1028700" indent="-342900">
+              <a:buFont typeface="Arial"/>
+              <a:buChar char="•"/>
+            </a:pPr>
+            <a:r>
+              <a:rPr lang="en-US" sz="1500">
                 <a:latin typeface="Arial"/>
               </a:rPr>
               <a:t>Level 3 Bullet</a:t>
             </a:r>
-            <a:r>
-              <a:rPr lang="en-US" sz="2200">
+          </a:p>
+          <a:p>
+            <a:pPr algn="l" lvl="3" marL="1371600" indent="-342900">
+              <a:buFont typeface="Arial"/>
+              <a:buChar char="•"/>
+            </a:pPr>
+            <a:r>
+              <a:rPr lang="en-US" sz="1500">
                 <a:latin typeface="Arial"/>
               </a:rPr>
               <a:t>Level 4 Bullet</a:t>
             </a:r>
-            <a:r>
-              <a:rPr lang="en-US" sz="2200">
+          </a:p>
+          <a:p>
+            <a:pPr algn="l" lvl="4" marL="1714500" indent="-342900">
+              <a:buFont typeface="Arial"/>
+              <a:buChar char="•"/>
+            </a:pPr>
+            <a:r>
+              <a:rPr lang="en-US" sz="1500">
                 <a:latin typeface="Arial"/>
               </a:rPr>
               <a:t>Level 5 Bullet</a:t>
@@ -97,13 +121,18 @@
               <a:buAutoNum type="arabicPeriod"/>
             </a:pPr>
             <a:r>
-              <a:rPr lang="en-US" sz="2200">
+              <a:rPr lang="en-US" sz="1500">
                 <a:latin typeface="Arial"/>
               </a:rPr>
               <a:t>Ordered List Item 1</a:t>
             </a:r>
-            <a:r>
-              <a:rPr lang="en-US" sz="2200">
+          </a:p>
+          <a:p>
+            <a:pPr algn="l" lvl="1" marL="685800" indent="-342900">
+              <a:buAutoNum type="arabicPeriod"/>
+            </a:pPr>
+            <a:r>
+              <a:rPr lang="en-US" sz="1500">
                 <a:latin typeface="Arial"/>
               </a:rPr>
               <a:t>Nested Ordered List Item 1</a:t>
@@ -114,7 +143,7 @@
               <a:buAutoNum type="arabicPeriod"/>
             </a:pPr>
             <a:r>
-              <a:rPr lang="en-US" sz="2200">
+              <a:rPr lang="en-US" sz="1500">
                 <a:latin typeface="Arial"/>
               </a:rPr>
               <a:t>Nested Ordered List Item 2</a:t>
@@ -125,13 +154,19 @@
               <a:buAutoNum type="arabicPeriod"/>
             </a:pPr>
             <a:r>
-              <a:rPr lang="en-US" sz="2200">
+              <a:rPr lang="en-US" sz="1500">
                 <a:latin typeface="Arial"/>
               </a:rPr>
               <a:t>Ordered List Item 2</a:t>
             </a:r>
-            <a:r>
-              <a:rPr lang="en-US" sz="2200">
+          </a:p>
+          <a:p>
+            <a:pPr algn="l" lvl="1" marL="685800" indent="-342900">
+              <a:buFont typeface="Arial"/>
+              <a:buChar char="•"/>
+            </a:pPr>
+            <a:r>
+              <a:rPr lang="en-US" sz="1500">
                 <a:latin typeface="Arial"/>
               </a:rPr>
               <a:t>Mixed Unordered Item 1</a:t>
@@ -143,7 +178,7 @@
               <a:buChar char="•"/>
             </a:pPr>
             <a:r>
-              <a:rPr lang="en-US" sz="2200">
+              <a:rPr lang="en-US" sz="1500">
                 <a:latin typeface="Arial"/>
               </a:rPr>
               <a:t>Mixed Unordered Item 2</a:t>
@@ -155,13 +190,19 @@
               <a:buChar char="•"/>
             </a:pPr>
             <a:r>
-              <a:rPr lang="en-US" sz="2200">
+              <a:rPr lang="en-US" sz="1500">
                 <a:latin typeface="Arial"/>
               </a:rPr>
               <a:t>A very long list item to test how text wraps when indented. We want to ensure that the second line of the bullet point lines up exactly with the first line of the text, rather than wrapping all the way to the left margin. This is crucial for readability.</a:t>
             </a:r>
-            <a:r>
-              <a:rPr lang="en-US" sz="2200">
+          </a:p>
+          <a:p>
+            <a:pPr algn="l" lvl="1" marL="685800" indent="-342900">
+              <a:buFont typeface="Arial"/>
+              <a:buChar char="•"/>
+            </a:pPr>
+            <a:r>
+              <a:rPr lang="en-US" sz="1500">
                 <a:latin typeface="Arial"/>
               </a:rPr>
               <a:t>Another very long nested list item to verify that the indentation margin is additive. The wrap margin should perfectly align with the bullet point's indent level.</a:t>

</xml_diff>